<commit_message>
Show company logo and QR on the number plate instead of a printed number
The registration number stays as a caption under the plate for lookups.
Refresh the overview deck screenshots to match.

Co-Authored-By: Claude Sonnet 5.5 <noreply@anthropic.com>
Claude-Session: https://claude.ai/code/session_01DwMvXGQxcAxL4J7CRLnDzp
</commit_message>
<xml_diff>
--- a/ev-registry/docs/EV-Pehchaan-deck.pptx
+++ b/ev-registry/docs/EV-Pehchaan-deck.pptx
@@ -116,7 +116,7 @@
   <p:extLst>
     <p:ext uri="{521415D9-36F7-43E2-AB2F-B90AF26B5E84}">
       <p14:sectionLst xmlns:p14="http://schemas.microsoft.com/office/powerpoint/2010/main">
-        <p14:section name="Overview" id="{150113e7-072a-9ce2-0f0b-ff67ee9129a4}">
+        <p14:section name="Overview" id="{da182851-8d52-3f43-4707-0f17074d5854}">
           <p14:sldIdLst>
             <p14:sldId id="256"/>
             <p14:sldId id="257"/>
@@ -124,19 +124,19 @@
             <p14:sldId id="259"/>
           </p14:sldIdLst>
         </p14:section>
-        <p14:section name="Company" id="{b5270160-b54a-8735-67f9-ff0b8439d777}">
+        <p14:section name="Company" id="{4e514a2f-10fd-6896-c59c-fddc723f6140}">
           <p14:sldIdLst>
             <p14:sldId id="260"/>
             <p14:sldId id="261"/>
           </p14:sldIdLst>
         </p14:section>
-        <p14:section name="Dealer and owner" id="{4e3685b7-194d-dd8c-f931-f8ccd3d95f4b}">
+        <p14:section name="Dealer and owner" id="{a133257b-5cc6-0efa-11dc-d56adc3d8f75}">
           <p14:sldIdLst>
             <p14:sldId id="262"/>
             <p14:sldId id="263"/>
           </p14:sldIdLst>
         </p14:section>
-        <p14:section name="Next" id="{78d2d78f-496b-78d7-469c-8c24a9f630d4}">
+        <p14:section name="Next" id="{fce45bef-d971-3c56-0d74-1abac934c86d}">
           <p14:sldIdLst>
             <p14:sldId id="264"/>
             <p14:sldId id="265"/>
@@ -2175,63 +2175,40 @@
           </a:p>
         </p:txBody>
       </p:sp>
-      <p:sp>
-        <p:nvSpPr>
-          <p:cNvPr id="4" name="Plate"/>
-          <p:cNvSpPr/>
-          <p:nvPr/>
-        </p:nvSpPr>
-        <p:spPr>
-          <a:xfrm>
-            <a:off x="640080" y="4983480"/>
-            <a:ext cx="4206240" cy="868680"/>
-          </a:xfrm>
-          <a:prstGeom prst="roundRect">
-            <a:avLst>
-              <a:gd name="adj" fmla="val 12632"/>
-            </a:avLst>
-          </a:prstGeom>
-          <a:solidFill>
-            <a:schemeClr val="accent2"/>
-          </a:solidFill>
-          <a:ln w="38100">
-            <a:solidFill>
-              <a:schemeClr val="tx1"/>
-            </a:solidFill>
-            <a:prstDash val="solid"/>
-          </a:ln>
-        </p:spPr>
-      </p:sp>
-      <p:sp>
-        <p:nvSpPr>
-          <p:cNvPr id="5" name="Plate tag"/>
-          <p:cNvSpPr/>
-          <p:nvPr/>
-        </p:nvSpPr>
-        <p:spPr>
-          <a:xfrm>
-            <a:off x="676656" y="5020056"/>
-            <a:ext cx="640080" cy="795528"/>
-          </a:xfrm>
-          <a:prstGeom prst="rect">
-            <a:avLst/>
-          </a:prstGeom>
-          <a:solidFill>
-            <a:schemeClr val="accent1"/>
-          </a:solidFill>
-          <a:ln/>
-        </p:spPr>
-      </p:sp>
-      <p:sp>
-        <p:nvSpPr>
-          <p:cNvPr id="6" name="Plate tag text"/>
+      <p:pic>
+        <p:nvPicPr>
+          <p:cNvPr id="4" name="Plate" descr="Number plate showing the Voltio Motors logo and a QR code">    </p:cNvPr>
+          <p:cNvPicPr>
+            <a:picLocks noChangeAspect="1"/>
+          </p:cNvPicPr>
+          <p:nvPr/>
+        </p:nvPicPr>
+        <p:blipFill>
+          <a:blip r:embed="rId1"/>
+          <a:stretch>
+            <a:fillRect/>
+          </a:stretch>
+        </p:blipFill>
+        <p:spPr>
+          <a:xfrm>
+            <a:off x="640080" y="4343400"/>
+            <a:ext cx="4206240" cy="1752600"/>
+          </a:xfrm>
+          <a:prstGeom prst="rect">
+            <a:avLst/>
+          </a:prstGeom>
+        </p:spPr>
+      </p:pic>
+      <p:sp>
+        <p:nvSpPr>
+          <p:cNvPr id="5" name="Footnote"/>
           <p:cNvSpPr txBox="1"/>
           <p:nvPr/>
         </p:nvSpPr>
         <p:spPr>
           <a:xfrm>
-            <a:off x="676656" y="5020056"/>
-            <a:ext cx="640080" cy="795528"/>
+            <a:off x="640080" y="6355080"/>
+            <a:ext cx="3657600" cy="274320"/>
           </a:xfrm>
           <a:prstGeom prst="rect">
             <a:avLst/>
@@ -2243,88 +2220,10 @@
           <a:bodyPr wrap="square" lIns="0" tIns="0" rIns="0" bIns="0" rtlCol="0" anchor="ctr"/>
           <a:lstStyle/>
           <a:p>
-            <a:pPr algn="ctr" indent="0" marL="0">
-              <a:buNone/>
-            </a:pPr>
-            <a:r>
-              <a:rPr lang="en-US" sz="1800" b="1" dirty="0">
-                <a:solidFill>
-                  <a:schemeClr val="bg1"/>
-                </a:solidFill>
-                <a:latin typeface="Courier New" pitchFamily="34" charset="0"/>
-                <a:ea typeface="Courier New" pitchFamily="34" charset="-122"/>
-                <a:cs typeface="Courier New" pitchFamily="34" charset="-120"/>
-              </a:rPr>
-              <a:t>EV</a:t>
-            </a:r>
-            <a:endParaRPr lang="en-US" sz="1800" dirty="0"/>
-          </a:p>
-        </p:txBody>
-      </p:sp>
-      <p:sp>
-        <p:nvSpPr>
-          <p:cNvPr id="7" name="Plate number"/>
-          <p:cNvSpPr txBox="1"/>
-          <p:nvPr/>
-        </p:nvSpPr>
-        <p:spPr>
-          <a:xfrm>
-            <a:off x="1417320" y="5020056"/>
-            <a:ext cx="3383280" cy="795528"/>
-          </a:xfrm>
-          <a:prstGeom prst="rect">
-            <a:avLst/>
-          </a:prstGeom>
-          <a:noFill/>
-          <a:ln/>
-        </p:spPr>
-        <p:txBody>
-          <a:bodyPr wrap="square" lIns="0" tIns="0" rIns="0" bIns="0" rtlCol="0" anchor="ctr"/>
-          <a:lstStyle/>
-          <a:p>
             <a:pPr indent="0" marL="0">
               <a:buNone/>
             </a:pPr>
             <a:r>
-              <a:rPr lang="en-US" sz="3000" b="1" dirty="0">
-                <a:solidFill>
-                  <a:schemeClr val="tx1"/>
-                </a:solidFill>
-                <a:latin typeface="Courier New" pitchFamily="34" charset="0"/>
-                <a:ea typeface="Courier New" pitchFamily="34" charset="-122"/>
-                <a:cs typeface="Courier New" pitchFamily="34" charset="-120"/>
-              </a:rPr>
-              <a:t>UP 24 004201</a:t>
-            </a:r>
-            <a:endParaRPr lang="en-US" sz="3000" dirty="0"/>
-          </a:p>
-        </p:txBody>
-      </p:sp>
-      <p:sp>
-        <p:nvSpPr>
-          <p:cNvPr id="8" name="Footnote"/>
-          <p:cNvSpPr txBox="1"/>
-          <p:nvPr/>
-        </p:nvSpPr>
-        <p:spPr>
-          <a:xfrm>
-            <a:off x="640080" y="6172200"/>
-            <a:ext cx="3657600" cy="274320"/>
-          </a:xfrm>
-          <a:prstGeom prst="rect">
-            <a:avLst/>
-          </a:prstGeom>
-          <a:noFill/>
-          <a:ln/>
-        </p:spPr>
-        <p:txBody>
-          <a:bodyPr wrap="square" lIns="0" tIns="0" rIns="0" bIns="0" rtlCol="0" anchor="ctr"/>
-          <a:lstStyle/>
-          <a:p>
-            <a:pPr indent="0" marL="0">
-              <a:buNone/>
-            </a:pPr>
-            <a:r>
               <a:rPr lang="en-US" sz="1200" dirty="0">
                 <a:solidFill>
                   <a:schemeClr val="accent4"/>
@@ -2338,7 +2237,7 @@
       </p:sp>
       <p:sp>
         <p:nvSpPr>
-          <p:cNvPr id="9" name="Owner home screen frame"/>
+          <p:cNvPr id="6" name="Owner home screen frame"/>
           <p:cNvSpPr/>
           <p:nvPr/>
         </p:nvSpPr>
@@ -2367,14 +2266,14 @@
       </p:sp>
       <p:pic>
         <p:nvPicPr>
-          <p:cNvPr id="10" name="Owner home screen" descr="Owner home screen">    </p:cNvPr>
+          <p:cNvPr id="7" name="Owner home screen" descr="Owner home screen">    </p:cNvPr>
           <p:cNvPicPr>
             <a:picLocks noChangeAspect="1"/>
           </p:cNvPicPr>
           <p:nvPr/>
         </p:nvPicPr>
         <p:blipFill>
-          <a:blip r:embed="rId1"/>
+          <a:blip r:embed="rId2"/>
           <a:stretch>
             <a:fillRect/>
           </a:stretch>
@@ -4433,7 +4332,7 @@
                   <a:schemeClr val="tx1"/>
                 </a:solidFill>
               </a:rPr>
-              <a:t>The bike gets an EV registration number and a QR code that opens its record.</a:t>
+              <a:t>The plate carries the company logo and a QR code that opens the bike's record.</a:t>
             </a:r>
             <a:endParaRPr lang="en-US" sz="1500" dirty="0"/>
           </a:p>

</xml_diff>